<commit_message>
chore(diagrams,docs): sync UML diagrams, report, and presentation with new admin commands
Update diagrams 02, 08, 11, 12 and regenerate the annual report and
defense presentation to reflect the three new admin commands
(/resetuser, /clearusers, /clearledger) and the corresponding
interface additions (IUserRepository.ResetAsync/ClearAllAsync,
IUserService.ResetUserAsync/ClearAllUsersAsync,
ILedgerRepository.ClearAsync, LedgerService.ClearAsync).
</commit_message>
<xml_diff>
--- a/raport/NurFlac_Prezentare.pptx
+++ b/raport/NurFlac_Prezentare.pptx
@@ -6285,18 +6285,40 @@
                   <a:srgbClr val="EAEAEA"/>
                 </a:solidFill>
               </a:rPr>
-              <a:t>HelpCommand verifică IsAdmin() şi afişează</a:t>
-            </a:r>
-          </a:p>
-          <a:p>
-            <a:pPr algn="l"/>
-            <a:r>
-              <a:rPr sz="1200">
-                <a:solidFill>
-                  <a:srgbClr val="EAEAEA"/>
-                </a:solidFill>
-              </a:rPr>
-              <a:t>secțiunea admin doar administratorilor.</a:t>
+              <a:t>Comenzi admin: /ban, /timeout, /unban,</a:t>
+            </a:r>
+          </a:p>
+          <a:p>
+            <a:pPr algn="l"/>
+            <a:r>
+              <a:rPr sz="1200">
+                <a:solidFill>
+                  <a:srgbClr val="EAEAEA"/>
+                </a:solidFill>
+              </a:rPr>
+              <a:t>/resetuser, /clearusers, /clearledger.</a:t>
+            </a:r>
+          </a:p>
+          <a:p>
+            <a:pPr algn="l"/>
+            <a:r>
+              <a:rPr sz="1200">
+                <a:solidFill>
+                  <a:srgbClr val="EAEAEA"/>
+                </a:solidFill>
+              </a:rPr>
+              <a:t>HelpCommand afişează secțiunea admin</a:t>
+            </a:r>
+          </a:p>
+          <a:p>
+            <a:pPr algn="l"/>
+            <a:r>
+              <a:rPr sz="1200">
+                <a:solidFill>
+                  <a:srgbClr val="EAEAEA"/>
+                </a:solidFill>
+              </a:rPr>
+              <a:t>doar administratorilor (IsAdmin()).</a:t>
             </a:r>
           </a:p>
         </p:txBody>
@@ -7563,7 +7585,7 @@
                   <a:srgbClr val="A0A8B8"/>
                 </a:solidFill>
               </a:rPr>
-              <a:t>Sesiune /album-upload cu mai multe fişiere → raport final  ·  Comenzi admin: /ban, /timeout, /unban</a:t>
+              <a:t>Sesiune /album-upload cu mai multe fişiere → raport final  ·  Comenzi admin: /ban, /timeout, /unban, /resetuser, /clearusers, /clearledger</a:t>
             </a:r>
           </a:p>
         </p:txBody>

</xml_diff>